<commit_message>
docs: refine editable final presentation template
</commit_message>
<xml_diff>
--- a/决赛提交的PPT/标准页模板/Pocket Earth 标准内容页-可编辑模板.pptx
+++ b/决赛提交的PPT/标准页模板/Pocket Earth 标准内容页-可编辑模板.pptx
@@ -1284,7 +1284,7 @@
         </p:nvSpPr>
         <p:spPr>
           <a:xfrm>
-            <a:off x="539737" y="5540322"/>
+            <a:off x="539737" y="5079959"/>
             <a:ext cx="3555911" cy="0"/>
           </a:xfrm>
           <a:prstGeom prst="line">
@@ -1327,7 +1327,7 @@
       </p:pic>
       <p:pic>
         <p:nvPicPr>
-          <p:cNvPr id="48" name="Pocket Earth Frost identity deck application view"/>
+          <p:cNvPr id="48" name="Pocket Earth public knowledge detail application view"/>
           <p:cNvPicPr/>
           <p:nvPr/>
         </p:nvPicPr>
@@ -1445,7 +1445,7 @@
         </p:nvSpPr>
         <p:spPr>
           <a:xfrm>
-            <a:off x="539737" y="904938"/>
+            <a:off x="539737" y="911288"/>
             <a:ext cx="2285943" cy="234944"/>
           </a:xfrm>
           <a:prstGeom prst="rect">
@@ -1457,12 +1457,12 @@
           </a:ln>
         </p:spPr>
         <p:txBody>
-          <a:bodyPr wrap="none" anchor="mid" lIns="0" tIns="0" rIns="0" bIns="0">
+          <a:bodyPr wrap="none" anchor="ctr" lIns="0" tIns="0" rIns="0" bIns="0">
             <a:noAutofit/>
           </a:bodyPr>
           <a:lstStyle/>
           <a:p>
-            <a:pPr algn="left"/>
+            <a:pPr algn="l"/>
             <a:r>
               <a:rPr lang="zh-CN" sz="1400">
                 <a:solidFill>
@@ -1472,7 +1472,7 @@
                 <a:ea typeface="Arial"/>
                 <a:cs typeface="Arial"/>
               </a:rPr>
-              <a:t>POCKET EARTH · INJECTIVE</a:t>
+              <a:t>PUBLIC EARTH · 公共知识层</a:t>
             </a:r>
             <a:endParaRPr lang="zh-CN" sz="1400"/>
           </a:p>
@@ -1486,8 +1486,8 @@
         </p:nvSpPr>
         <p:spPr>
           <a:xfrm>
-            <a:off x="523862" y="1412925"/>
-            <a:ext cx="3682908" cy="952476"/>
+            <a:off x="523862" y="1435150"/>
+            <a:ext cx="3873403" cy="603235"/>
           </a:xfrm>
           <a:prstGeom prst="rect">
             <a:avLst/>
@@ -1498,14 +1498,14 @@
           </a:ln>
         </p:spPr>
         <p:txBody>
-          <a:bodyPr wrap="none" anchor="top" lIns="0" tIns="0" rIns="0" bIns="0">
+          <a:bodyPr wrap="none" anchor="t" lIns="0" tIns="0" rIns="0" bIns="0">
             <a:noAutofit/>
           </a:bodyPr>
           <a:lstStyle/>
           <a:p>
-            <a:pPr algn="left"/>
+            <a:pPr algn="l"/>
             <a:r>
-              <a:rPr lang="zh-CN" sz="3100">
+              <a:rPr lang="zh-CN" sz="2800">
                 <a:solidFill>
                   <a:srgbClr val="17191A"/>
                 </a:solidFill>
@@ -1513,24 +1513,9 @@
                 <a:ea typeface="PingFang SC"/>
                 <a:cs typeface="PingFang SC"/>
               </a:rPr>
-              <a:t>一个地球，</a:t>
+              <a:t>把新闻炼成可验证知识</a:t>
             </a:r>
-            <a:endParaRPr lang="zh-CN" sz="3100"/>
-          </a:p>
-          <a:p>
-            <a:pPr algn="left"/>
-            <a:r>
-              <a:rPr lang="zh-CN" sz="3100">
-                <a:solidFill>
-                  <a:srgbClr val="17191A"/>
-                </a:solidFill>
-                <a:latin typeface="PingFang SC"/>
-                <a:ea typeface="PingFang SC"/>
-                <a:cs typeface="PingFang SC"/>
-              </a:rPr>
-              <a:t>两层知识</a:t>
-            </a:r>
-            <a:endParaRPr lang="zh-CN" sz="3100"/>
+            <a:endParaRPr lang="zh-CN" sz="2800"/>
           </a:p>
         </p:txBody>
       </p:sp>
@@ -1542,8 +1527,8 @@
         </p:nvSpPr>
         <p:spPr>
           <a:xfrm>
-            <a:off x="539737" y="2476524"/>
-            <a:ext cx="3809905" cy="253994"/>
+            <a:off x="539737" y="2174906"/>
+            <a:ext cx="3873403" cy="273043"/>
           </a:xfrm>
           <a:prstGeom prst="rect">
             <a:avLst/>
@@ -1554,14 +1539,14 @@
           </a:ln>
         </p:spPr>
         <p:txBody>
-          <a:bodyPr wrap="none" anchor="top" lIns="0" tIns="0" rIns="0" bIns="0">
+          <a:bodyPr wrap="none" anchor="t" lIns="0" tIns="0" rIns="0" bIns="0">
             <a:noAutofit/>
           </a:bodyPr>
           <a:lstStyle/>
           <a:p>
-            <a:pPr algn="left"/>
+            <a:pPr algn="l"/>
             <a:r>
-              <a:rPr lang="zh-CN" sz="1400">
+              <a:rPr lang="zh-CN" sz="1450">
                 <a:solidFill>
                   <a:srgbClr val="238FD0"/>
                 </a:solidFill>
@@ -1569,9 +1554,9 @@
                 <a:ea typeface="PingFang SC"/>
                 <a:cs typeface="PingFang SC"/>
               </a:rPr>
-              <a:t>私人记忆 · 公共知识 · 链上可验证</a:t>
+              <a:t>8 个领域 Agent · 7 天热缓存 · 每日 Merkle 版次</a:t>
             </a:r>
-            <a:endParaRPr lang="zh-CN" sz="1400"/>
+            <a:endParaRPr lang="zh-CN" sz="1450"/>
           </a:p>
         </p:txBody>
       </p:sp>
@@ -1583,8 +1568,8 @@
         </p:nvSpPr>
         <p:spPr>
           <a:xfrm>
-            <a:off x="539737" y="2952762"/>
-            <a:ext cx="3746406" cy="2222444"/>
+            <a:off x="539737" y="2635270"/>
+            <a:ext cx="3778156" cy="2095448"/>
           </a:xfrm>
           <a:prstGeom prst="rect">
             <a:avLst/>
@@ -1595,14 +1580,14 @@
           </a:ln>
         </p:spPr>
         <p:txBody>
-          <a:bodyPr wrap="none" anchor="top" lIns="0" tIns="0" rIns="0" bIns="0">
+          <a:bodyPr wrap="none" anchor="t" lIns="0" tIns="0" rIns="0" bIns="0">
             <a:noAutofit/>
           </a:bodyPr>
           <a:lstStyle/>
           <a:p>
-            <a:pPr algn="left"/>
+            <a:pPr algn="l"/>
             <a:r>
-              <a:rPr lang="zh-CN" sz="1250">
+              <a:rPr lang="zh-CN" sz="1160">
                 <a:solidFill>
                   <a:srgbClr val="5C6264"/>
                 </a:solidFill>
@@ -1610,14 +1595,14 @@
                 <a:ea typeface="PingFang SC"/>
                 <a:cs typeface="PingFang SC"/>
               </a:rPr>
-              <a:t>Pocket Earth 把两种完全不同的知识放进</a:t>
+              <a:t>私人地图保存只属于你的空间记忆。</a:t>
             </a:r>
-            <a:endParaRPr lang="zh-CN" sz="1250"/>
+            <a:endParaRPr lang="zh-CN" sz="1160"/>
           </a:p>
           <a:p>
-            <a:pPr algn="left"/>
+            <a:pPr algn="l"/>
             <a:r>
-              <a:rPr lang="zh-CN" sz="1250">
+              <a:rPr lang="zh-CN" sz="1160">
                 <a:solidFill>
                   <a:srgbClr val="5C6264"/>
                 </a:solidFill>
@@ -1625,14 +1610,14 @@
                 <a:ea typeface="PingFang SC"/>
                 <a:cs typeface="PingFang SC"/>
               </a:rPr>
-              <a:t>同一颗地球：私人地图承载只属于你的空间</a:t>
+              <a:t>公共地球则由 8 个领域 Agent 搜集、</a:t>
             </a:r>
-            <a:endParaRPr lang="zh-CN" sz="1250"/>
+            <a:endParaRPr lang="zh-CN" sz="1160"/>
           </a:p>
           <a:p>
-            <a:pPr algn="left"/>
+            <a:pPr algn="l"/>
             <a:r>
-              <a:rPr lang="zh-CN" sz="1250">
+              <a:rPr lang="zh-CN" sz="1160">
                 <a:solidFill>
                   <a:srgbClr val="5C6264"/>
                 </a:solidFill>
@@ -1640,14 +1625,14 @@
                 <a:ea typeface="PingFang SC"/>
                 <a:cs typeface="PingFang SC"/>
               </a:rPr>
-              <a:t>记忆；公共地球由领域 Agent 持续筛选、</a:t>
+              <a:t>筛选与交叉验证；新闻卡片落在真实地点，</a:t>
             </a:r>
-            <a:endParaRPr lang="zh-CN" sz="1250"/>
+            <a:endParaRPr lang="zh-CN" sz="1160"/>
           </a:p>
           <a:p>
-            <a:pPr algn="left"/>
+            <a:pPr algn="l"/>
             <a:r>
-              <a:rPr lang="zh-CN" sz="1250">
+              <a:rPr lang="zh-CN" sz="1160">
                 <a:solidFill>
                   <a:srgbClr val="5C6264"/>
                 </a:solidFill>
@@ -1655,14 +1640,14 @@
                 <a:ea typeface="PingFang SC"/>
                 <a:cs typeface="PingFang SC"/>
               </a:rPr>
-              <a:t>交叉验证并发布知识版次。</a:t>
+              <a:t>可从地图上的缩略信号展开为完整内容。</a:t>
             </a:r>
-            <a:endParaRPr lang="zh-CN" sz="1250"/>
+            <a:endParaRPr lang="zh-CN" sz="1160"/>
           </a:p>
           <a:p>
-            <a:pPr algn="left"/>
+            <a:pPr algn="l"/>
             <a:r>
-              <a:rPr lang="zh-CN" sz="1250">
+              <a:rPr lang="zh-CN" sz="1160">
                 <a:solidFill>
                   <a:srgbClr val="5C6264"/>
                 </a:solidFill>
@@ -1672,12 +1657,12 @@
               </a:rPr>
               <a:t/>
             </a:r>
-            <a:endParaRPr lang="zh-CN" sz="1250"/>
+            <a:endParaRPr lang="zh-CN" sz="1160"/>
           </a:p>
           <a:p>
-            <a:pPr algn="left"/>
+            <a:pPr algn="l"/>
             <a:r>
-              <a:rPr lang="zh-CN" sz="1250">
+              <a:rPr lang="zh-CN" sz="1160">
                 <a:solidFill>
                   <a:srgbClr val="5C6264"/>
                 </a:solidFill>
@@ -1685,14 +1670,14 @@
                 <a:ea typeface="PingFang SC"/>
                 <a:cs typeface="PingFang SC"/>
               </a:rPr>
-              <a:t>原始内容留在链下，身份与每日版次根锚定</a:t>
+              <a:t>丰富内容留在链下；每日精选知识生成</a:t>
             </a:r>
-            <a:endParaRPr lang="zh-CN" sz="1250"/>
+            <a:endParaRPr lang="zh-CN" sz="1160"/>
           </a:p>
           <a:p>
-            <a:pPr algn="left"/>
+            <a:pPr algn="l"/>
             <a:r>
-              <a:rPr lang="zh-CN" sz="1250">
+              <a:rPr lang="zh-CN" sz="1160">
                 <a:solidFill>
                   <a:srgbClr val="5C6264"/>
                 </a:solidFill>
@@ -1700,14 +1685,14 @@
                 <a:ea typeface="PingFang SC"/>
                 <a:cs typeface="PingFang SC"/>
               </a:rPr>
-              <a:t>Injective。用户看到的不只是新闻列表，</a:t>
+              <a:t>Merkle 根并锚定 Injective。用户得到的是</a:t>
             </a:r>
-            <a:endParaRPr lang="zh-CN" sz="1250"/>
+            <a:endParaRPr lang="zh-CN" sz="1160"/>
           </a:p>
           <a:p>
-            <a:pPr algn="left"/>
+            <a:pPr algn="l"/>
             <a:r>
-              <a:rPr lang="zh-CN" sz="1250">
+              <a:rPr lang="zh-CN" sz="1160">
                 <a:solidFill>
                   <a:srgbClr val="5C6264"/>
                 </a:solidFill>
@@ -1715,14 +1700,14 @@
                 <a:ea typeface="PingFang SC"/>
                 <a:cs typeface="PingFang SC"/>
               </a:rPr>
-              <a:t>而是一张可以定位、展开并独立验真的</a:t>
+              <a:t>一份可定位、可下载、可独立验真的</a:t>
             </a:r>
-            <a:endParaRPr lang="zh-CN" sz="1250"/>
+            <a:endParaRPr lang="zh-CN" sz="1160"/>
           </a:p>
           <a:p>
-            <a:pPr algn="left"/>
+            <a:pPr algn="l"/>
             <a:r>
-              <a:rPr lang="zh-CN" sz="1250">
+              <a:rPr lang="zh-CN" sz="1160">
                 <a:solidFill>
                   <a:srgbClr val="5C6264"/>
                 </a:solidFill>
@@ -1730,9 +1715,9 @@
                 <a:ea typeface="PingFang SC"/>
                 <a:cs typeface="PingFang SC"/>
               </a:rPr>
-              <a:t>公共知识地图。</a:t>
+              <a:t>公共知识版次。</a:t>
             </a:r>
-            <a:endParaRPr lang="zh-CN" sz="1250"/>
+            <a:endParaRPr lang="zh-CN" sz="1160"/>
           </a:p>
         </p:txBody>
       </p:sp>
@@ -1744,8 +1729,8 @@
         </p:nvSpPr>
         <p:spPr>
           <a:xfrm>
-            <a:off x="5032249" y="5810190"/>
-            <a:ext cx="2476438" cy="476238"/>
+            <a:off x="5000500" y="5829240"/>
+            <a:ext cx="2698683" cy="368291"/>
           </a:xfrm>
           <a:prstGeom prst="rect">
             <a:avLst/>
@@ -1756,14 +1741,14 @@
           </a:ln>
         </p:spPr>
         <p:txBody>
-          <a:bodyPr wrap="square" anchor="top" lIns="0" tIns="0" rIns="0" bIns="0">
+          <a:bodyPr wrap="square" anchor="t" lIns="0" tIns="0" rIns="0" bIns="0">
             <a:noAutofit/>
           </a:bodyPr>
           <a:lstStyle/>
           <a:p>
-            <a:pPr algn="center"/>
+            <a:pPr algn="ctr"/>
             <a:r>
-              <a:rPr lang="zh-CN" sz="1250">
+              <a:rPr lang="zh-CN" sz="1280">
                 <a:solidFill>
                   <a:srgbClr val="4F5557"/>
                 </a:solidFill>
@@ -1771,9 +1756,9 @@
                 <a:ea typeface="PingFang SC"/>
                 <a:cs typeface="PingFang SC"/>
               </a:rPr>
-              <a:t>知识地图：8 个领域信号贴在公共地球上</a:t>
+              <a:t>知识地图 · 新闻信号被钉在真实地点</a:t>
             </a:r>
-            <a:endParaRPr lang="zh-CN" sz="1250"/>
+            <a:endParaRPr lang="zh-CN" sz="1280"/>
           </a:p>
         </p:txBody>
       </p:sp>
@@ -1785,8 +1770,8 @@
         </p:nvSpPr>
         <p:spPr>
           <a:xfrm>
-            <a:off x="8985025" y="5810190"/>
-            <a:ext cx="2603435" cy="476238"/>
+            <a:off x="8921527" y="5829240"/>
+            <a:ext cx="2698683" cy="368291"/>
           </a:xfrm>
           <a:prstGeom prst="rect">
             <a:avLst/>
@@ -1797,14 +1782,14 @@
           </a:ln>
         </p:spPr>
         <p:txBody>
-          <a:bodyPr wrap="square" anchor="top" lIns="0" tIns="0" rIns="0" bIns="0">
+          <a:bodyPr wrap="square" anchor="t" lIns="0" tIns="0" rIns="0" bIns="0">
             <a:noAutofit/>
           </a:bodyPr>
           <a:lstStyle/>
           <a:p>
-            <a:pPr algn="center"/>
+            <a:pPr algn="ctr"/>
             <a:r>
-              <a:rPr lang="zh-CN" sz="1250">
+              <a:rPr lang="zh-CN" sz="1280">
                 <a:solidFill>
                   <a:srgbClr val="4F5557"/>
                 </a:solidFill>
@@ -1812,9 +1797,9 @@
                 <a:ea typeface="PingFang SC"/>
                 <a:cs typeface="PingFang SC"/>
               </a:rPr>
-              <a:t>身份卡牌：FROST 链上身份可携带、可验证</a:t>
+              <a:t>知识详情 · 一张卡片展开成完整内容</a:t>
             </a:r>
-            <a:endParaRPr lang="zh-CN" sz="1250"/>
+            <a:endParaRPr lang="zh-CN" sz="1280"/>
           </a:p>
         </p:txBody>
       </p:sp>
@@ -1838,12 +1823,12 @@
           </a:ln>
         </p:spPr>
         <p:txBody>
-          <a:bodyPr wrap="none" anchor="top" lIns="0" tIns="0" rIns="0" bIns="0">
+          <a:bodyPr wrap="none" anchor="t" lIns="0" tIns="0" rIns="0" bIns="0">
             <a:noAutofit/>
           </a:bodyPr>
           <a:lstStyle/>
           <a:p>
-            <a:pPr algn="left"/>
+            <a:pPr algn="l"/>
             <a:r>
               <a:rPr lang="zh-CN" sz="950">
                 <a:solidFill>
@@ -1853,7 +1838,7 @@
                 <a:ea typeface="Arial"/>
                 <a:cs typeface="Arial"/>
               </a:rPr>
-              <a:t>01 / PRODUCT LOGIC</a:t>
+              <a:t>01 / PUBLIC KNOWLEDGE</a:t>
             </a:r>
             <a:endParaRPr lang="zh-CN" sz="950"/>
           </a:p>

</xml_diff>